<commit_message>
refactor: restructure AIL unit as a standalone 50-hour hours-based plan (not weeks)
- Unit model changes from weeks to hours: phases (orientation, the four
  objectives, consolidation) containing blocks with facilitatedHours /
  independentHours, plus connective blocks (orientation, goal-pursuit practice,
  showcase) that carry a description instead of a material. Totals validated to
  30h in-person + 20h independent = 50h.
- Times are generous (~1.5-2x a literate-group estimate) for this oral/visual,
  translated, largely pre-literate cohort; AIL is treated as a standalone
  component running one full self-directed-learning cycle on a real goal.
- Unit page and the three editable downloads (facilitator plan, workbook,
  slides) regenerated for the hours/phases structure.

Co-Authored-By: Claude Opus 4.8 <noreply@anthropic.com>
</commit_message>
<xml_diff>
--- a/public/downloads/agency-in-learning-slides.pptx
+++ b/public/downloads/agency-in-learning-slides.pptx
@@ -3410,7 +3410,7 @@
                 </a:solidFill>
                 <a:latin typeface="Calibri"/>
               </a:rPr>
-              <a:t>Week 2 — Set clear, meaningful learning goals</a:t>
+              <a:t>Set clear, meaningful learning goals</a:t>
             </a:r>
           </a:p>
         </p:txBody>
@@ -4309,7 +4309,7 @@
                 </a:solidFill>
                 <a:latin typeface="Calibri"/>
               </a:rPr>
-              <a:t>Week 1 — Understand yourself as a learner</a:t>
+              <a:t>Understand yourself as a learner</a:t>
             </a:r>
           </a:p>
         </p:txBody>
@@ -4466,7 +4466,7 @@
                 </a:solidFill>
                 <a:latin typeface="Calibri"/>
               </a:rPr>
-              <a:t>Week 3 — Plan and take deliberate steps</a:t>
+              <a:t>Plan and take deliberate steps</a:t>
             </a:r>
           </a:p>
         </p:txBody>
@@ -5103,7 +5103,7 @@
                 </a:solidFill>
                 <a:latin typeface="Calibri"/>
               </a:rPr>
-              <a:t>Week 4 — Track, feedback, reflect</a:t>
+              <a:t>Track, feedback, and reflect</a:t>
             </a:r>
           </a:p>
         </p:txBody>

</xml_diff>

<commit_message>
feat: add an "explore the objectives" orientation to the AIL first phase
- New reusable, component-agnostic orientation activity `exploring-your-
  objectives` (main-site generic): learners unpack a course's objectives,
  discuss why each matters, clarify the words and ask questions, then say how
  they would approach each — surfacing prior knowledge so the facilitator can
  adjust. Applies to any component, including the Research Project.
- Cox's Bazar edition `cb-ail-exploring-our-objectives`: oral/visual, the four
  AIL objectives as pictures, words taught plainly with room for questions, and
  a listening step that reads the group's starting point.
- Added to the unit's Getting started phase (2.5h) and rebalanced other blocks
  so the component stays at 50h (30 in-person + 20 independent). Downloads
  regenerated.

Co-Authored-By: Claude Opus 4.8 <noreply@anthropic.com>
</commit_message>
<xml_diff>
--- a/public/downloads/agency-in-learning-slides.pptx
+++ b/public/downloads/agency-in-learning-slides.pptx
@@ -39,6 +39,9 @@
     <p:sldId id="287" r:id="rId38"/>
     <p:sldId id="288" r:id="rId39"/>
     <p:sldId id="289" r:id="rId40"/>
+    <p:sldId id="290" r:id="rId41"/>
+    <p:sldId id="291" r:id="rId42"/>
+    <p:sldId id="292" r:id="rId43"/>
   </p:sldIdLst>
   <p:sldSz cx="12191695" cy="6858000" type="screen4x3"/>
   <p:notesSz cx="6858000" cy="9144000"/>
@@ -3272,7 +3275,7 @@
     <p:bg>
       <p:bgPr>
         <a:solidFill>
-          <a:srgbClr val="E1EEF1"/>
+          <a:srgbClr val="FFFFFF"/>
         </a:solidFill>
         <a:effectLst/>
       </p:bgPr>
@@ -3292,7 +3295,7 @@
         </p:nvSpPr>
         <p:spPr>
           <a:xfrm>
-            <a:off x="822960" y="822960"/>
+            <a:off x="822960" y="640080"/>
             <a:ext cx="10515600" cy="457200"/>
           </a:xfrm>
           <a:prstGeom prst="rect">
@@ -3308,13 +3311,13 @@
           <a:p>
             <a:pPr algn="ctr"/>
             <a:r>
-              <a:rPr sz="1600" b="1" spc="300">
-                <a:solidFill>
-                  <a:srgbClr val="3F8291"/>
-                </a:solidFill>
-                <a:latin typeface="Calibri"/>
-              </a:rPr>
-              <a:t>DO</a:t>
+              <a:rPr sz="1500" b="1" spc="300">
+                <a:solidFill>
+                  <a:srgbClr val="EF9600"/>
+                </a:solidFill>
+                <a:latin typeface="Calibri"/>
+              </a:rPr>
+              <a:t>SESSION 2 · WHAT I WANT TO GROW</a:t>
             </a:r>
           </a:p>
         </p:txBody>
@@ -3327,29 +3330,29 @@
         </p:nvSpPr>
         <p:spPr>
           <a:xfrm>
-            <a:off x="822960" y="2560320"/>
-            <a:ext cx="10515600" cy="1828800"/>
-          </a:xfrm>
-          <a:prstGeom prst="rect">
-            <a:avLst/>
-          </a:prstGeom>
-          <a:noFill/>
-        </p:spPr>
-        <p:txBody>
-          <a:bodyPr wrap="square" anchor="ctr">
-            <a:spAutoFit/>
-          </a:bodyPr>
-          <a:lstStyle/>
-          <a:p>
-            <a:pPr algn="ctr"/>
-            <a:r>
-              <a:rPr sz="4000" b="1">
-                <a:solidFill>
-                  <a:srgbClr val="041E42"/>
-                </a:solidFill>
-                <a:latin typeface="Calibri"/>
-              </a:rPr>
-              <a:t>For two days, notice when and where you focus best.</a:t>
+            <a:off x="822960" y="2468880"/>
+            <a:ext cx="10515600" cy="2011680"/>
+          </a:xfrm>
+          <a:prstGeom prst="rect">
+            <a:avLst/>
+          </a:prstGeom>
+          <a:noFill/>
+        </p:spPr>
+        <p:txBody>
+          <a:bodyPr wrap="square" anchor="ctr">
+            <a:spAutoFit/>
+          </a:bodyPr>
+          <a:lstStyle/>
+          <a:p>
+            <a:pPr algn="ctr"/>
+            <a:r>
+              <a:rPr sz="4600" b="1">
+                <a:solidFill>
+                  <a:srgbClr val="004976"/>
+                </a:solidFill>
+                <a:latin typeface="Calibri"/>
+              </a:rPr>
+              <a:t>What do I want to grow?</a:t>
             </a:r>
           </a:p>
         </p:txBody>
@@ -3368,7 +3371,7 @@
     <p:bg>
       <p:bgPr>
         <a:solidFill>
-          <a:srgbClr val="004976"/>
+          <a:srgbClr val="E1EEF1"/>
         </a:solidFill>
         <a:effectLst/>
       </p:bgPr>
@@ -3388,8 +3391,43 @@
         </p:nvSpPr>
         <p:spPr>
           <a:xfrm>
-            <a:off x="822960" y="2651760"/>
-            <a:ext cx="10515600" cy="1645920"/>
+            <a:off x="822960" y="822960"/>
+            <a:ext cx="10515600" cy="457200"/>
+          </a:xfrm>
+          <a:prstGeom prst="rect">
+            <a:avLst/>
+          </a:prstGeom>
+          <a:noFill/>
+        </p:spPr>
+        <p:txBody>
+          <a:bodyPr wrap="square" anchor="ctr">
+            <a:spAutoFit/>
+          </a:bodyPr>
+          <a:lstStyle/>
+          <a:p>
+            <a:pPr algn="ctr"/>
+            <a:r>
+              <a:rPr sz="1600" b="1" spc="300">
+                <a:solidFill>
+                  <a:srgbClr val="3F8291"/>
+                </a:solidFill>
+                <a:latin typeface="Calibri"/>
+              </a:rPr>
+              <a:t>DO</a:t>
+            </a:r>
+          </a:p>
+        </p:txBody>
+      </p:sp>
+      <p:sp>
+        <p:nvSpPr>
+          <p:cNvPr id="3" name="TextBox 2"/>
+          <p:cNvSpPr txBox="1"/>
+          <p:nvPr/>
+        </p:nvSpPr>
+        <p:spPr>
+          <a:xfrm>
+            <a:off x="822960" y="2560320"/>
+            <a:ext cx="10515600" cy="1828800"/>
           </a:xfrm>
           <a:prstGeom prst="rect">
             <a:avLst/>
@@ -3406,11 +3444,11 @@
             <a:r>
               <a:rPr sz="4000" b="1">
                 <a:solidFill>
-                  <a:srgbClr val="FFFFFF"/>
-                </a:solidFill>
-                <a:latin typeface="Calibri"/>
-              </a:rPr>
-              <a:t>Set clear, meaningful learning goals</a:t>
+                  <a:srgbClr val="041E42"/>
+                </a:solidFill>
+                <a:latin typeface="Calibri"/>
+              </a:rPr>
+              <a:t>Draw your strengths. Hear what others see in you.</a:t>
             </a:r>
           </a:p>
         </p:txBody>
@@ -3471,7 +3509,7 @@
                 </a:solidFill>
                 <a:latin typeface="Calibri"/>
               </a:rPr>
-              <a:t>SESSION 1 · WHAT MAKES A GOOD GOAL</a:t>
+              <a:t>SESSION 3 · HOW I LEARN BEST</a:t>
             </a:r>
           </a:p>
         </p:txBody>
@@ -3484,7 +3522,7 @@
         </p:nvSpPr>
         <p:spPr>
           <a:xfrm>
-            <a:off x="822960" y="2468880"/>
+            <a:off x="822960" y="2194560"/>
             <a:ext cx="10515600" cy="2011680"/>
           </a:xfrm>
           <a:prstGeom prst="rect">
@@ -3506,7 +3544,42 @@
                 </a:solidFill>
                 <a:latin typeface="Calibri"/>
               </a:rPr>
-              <a:t>Small · Clear · It matters · By when</a:t>
+              <a:t>How do I learn best?</a:t>
+            </a:r>
+          </a:p>
+        </p:txBody>
+      </p:sp>
+      <p:sp>
+        <p:nvSpPr>
+          <p:cNvPr id="4" name="TextBox 3"/>
+          <p:cNvSpPr txBox="1"/>
+          <p:nvPr/>
+        </p:nvSpPr>
+        <p:spPr>
+          <a:xfrm>
+            <a:off x="822960" y="4206240"/>
+            <a:ext cx="10515600" cy="1463040"/>
+          </a:xfrm>
+          <a:prstGeom prst="rect">
+            <a:avLst/>
+          </a:prstGeom>
+          <a:noFill/>
+        </p:spPr>
+        <p:txBody>
+          <a:bodyPr wrap="square" anchor="ctr">
+            <a:spAutoFit/>
+          </a:bodyPr>
+          <a:lstStyle/>
+          <a:p>
+            <a:pPr algn="ctr"/>
+            <a:r>
+              <a:rPr sz="2600" b="0">
+                <a:solidFill>
+                  <a:srgbClr val="041E42"/>
+                </a:solidFill>
+                <a:latin typeface="Calibri"/>
+              </a:rPr>
+              <a:t>When? Where? Who and what helps me?</a:t>
             </a:r>
           </a:p>
         </p:txBody>
@@ -3520,137 +3593,6 @@
 </file>
 
 <file path=ppt/slides/slide13.xml><?xml version="1.0" encoding="utf-8"?>
-<p:sld xmlns:a="http://schemas.openxmlformats.org/drawingml/2006/main" xmlns:p="http://schemas.openxmlformats.org/presentationml/2006/main" xmlns:r="http://schemas.openxmlformats.org/officeDocument/2006/relationships">
-  <p:cSld>
-    <p:bg>
-      <p:bgPr>
-        <a:solidFill>
-          <a:srgbClr val="FFFFFF"/>
-        </a:solidFill>
-        <a:effectLst/>
-      </p:bgPr>
-    </p:bg>
-    <p:spTree>
-      <p:nvGrpSpPr>
-        <p:cNvPr id="1" name=""/>
-        <p:cNvGrpSpPr/>
-        <p:nvPr/>
-      </p:nvGrpSpPr>
-      <p:grpSpPr/>
-      <p:sp>
-        <p:nvSpPr>
-          <p:cNvPr id="2" name="TextBox 1"/>
-          <p:cNvSpPr txBox="1"/>
-          <p:nvPr/>
-        </p:nvSpPr>
-        <p:spPr>
-          <a:xfrm>
-            <a:off x="822960" y="640080"/>
-            <a:ext cx="10515600" cy="457200"/>
-          </a:xfrm>
-          <a:prstGeom prst="rect">
-            <a:avLst/>
-          </a:prstGeom>
-          <a:noFill/>
-        </p:spPr>
-        <p:txBody>
-          <a:bodyPr wrap="square" anchor="ctr">
-            <a:spAutoFit/>
-          </a:bodyPr>
-          <a:lstStyle/>
-          <a:p>
-            <a:pPr algn="ctr"/>
-            <a:r>
-              <a:rPr sz="1500" b="1" spc="300">
-                <a:solidFill>
-                  <a:srgbClr val="EF9600"/>
-                </a:solidFill>
-                <a:latin typeface="Calibri"/>
-              </a:rPr>
-              <a:t>SESSION 1 · WHAT MAKES A GOOD GOAL</a:t>
-            </a:r>
-          </a:p>
-        </p:txBody>
-      </p:sp>
-      <p:sp>
-        <p:nvSpPr>
-          <p:cNvPr id="3" name="TextBox 2"/>
-          <p:cNvSpPr txBox="1"/>
-          <p:nvPr/>
-        </p:nvSpPr>
-        <p:spPr>
-          <a:xfrm>
-            <a:off x="822960" y="2194560"/>
-            <a:ext cx="10515600" cy="2011680"/>
-          </a:xfrm>
-          <a:prstGeom prst="rect">
-            <a:avLst/>
-          </a:prstGeom>
-          <a:noFill/>
-        </p:spPr>
-        <p:txBody>
-          <a:bodyPr wrap="square" anchor="ctr">
-            <a:spAutoFit/>
-          </a:bodyPr>
-          <a:lstStyle/>
-          <a:p>
-            <a:pPr algn="ctr"/>
-            <a:r>
-              <a:rPr sz="4600" b="1">
-                <a:solidFill>
-                  <a:srgbClr val="004976"/>
-                </a:solidFill>
-                <a:latin typeface="Calibri"/>
-              </a:rPr>
-              <a:t>A wish is big and far.</a:t>
-            </a:r>
-          </a:p>
-        </p:txBody>
-      </p:sp>
-      <p:sp>
-        <p:nvSpPr>
-          <p:cNvPr id="4" name="TextBox 3"/>
-          <p:cNvSpPr txBox="1"/>
-          <p:nvPr/>
-        </p:nvSpPr>
-        <p:spPr>
-          <a:xfrm>
-            <a:off x="822960" y="4206240"/>
-            <a:ext cx="10515600" cy="1463040"/>
-          </a:xfrm>
-          <a:prstGeom prst="rect">
-            <a:avLst/>
-          </a:prstGeom>
-          <a:noFill/>
-        </p:spPr>
-        <p:txBody>
-          <a:bodyPr wrap="square" anchor="ctr">
-            <a:spAutoFit/>
-          </a:bodyPr>
-          <a:lstStyle/>
-          <a:p>
-            <a:pPr algn="ctr"/>
-            <a:r>
-              <a:rPr sz="2600" b="0">
-                <a:solidFill>
-                  <a:srgbClr val="041E42"/>
-                </a:solidFill>
-                <a:latin typeface="Calibri"/>
-              </a:rPr>
-              <a:t>A goal is small and near, and you can tell when you reach it.</a:t>
-            </a:r>
-          </a:p>
-        </p:txBody>
-      </p:sp>
-    </p:spTree>
-  </p:cSld>
-  <p:clrMapOvr>
-    <a:masterClrMapping/>
-  </p:clrMapOvr>
-</p:sld>
-</file>
-
-<file path=ppt/slides/slide14.xml><?xml version="1.0" encoding="utf-8"?>
 <p:sld xmlns:a="http://schemas.openxmlformats.org/drawingml/2006/main" xmlns:p="http://schemas.openxmlformats.org/presentationml/2006/main" xmlns:r="http://schemas.openxmlformats.org/officeDocument/2006/relationships">
   <p:cSld>
     <p:bg>
@@ -3733,7 +3675,68 @@
                 </a:solidFill>
                 <a:latin typeface="Calibri"/>
               </a:rPr>
-              <a:t>Judge these goals together: thumbs up or thumbs down.</a:t>
+              <a:t>For two days, notice when and where you focus best.</a:t>
+            </a:r>
+          </a:p>
+        </p:txBody>
+      </p:sp>
+    </p:spTree>
+  </p:cSld>
+  <p:clrMapOvr>
+    <a:masterClrMapping/>
+  </p:clrMapOvr>
+</p:sld>
+</file>
+
+<file path=ppt/slides/slide14.xml><?xml version="1.0" encoding="utf-8"?>
+<p:sld xmlns:a="http://schemas.openxmlformats.org/drawingml/2006/main" xmlns:p="http://schemas.openxmlformats.org/presentationml/2006/main" xmlns:r="http://schemas.openxmlformats.org/officeDocument/2006/relationships">
+  <p:cSld>
+    <p:bg>
+      <p:bgPr>
+        <a:solidFill>
+          <a:srgbClr val="004976"/>
+        </a:solidFill>
+        <a:effectLst/>
+      </p:bgPr>
+    </p:bg>
+    <p:spTree>
+      <p:nvGrpSpPr>
+        <p:cNvPr id="1" name=""/>
+        <p:cNvGrpSpPr/>
+        <p:nvPr/>
+      </p:nvGrpSpPr>
+      <p:grpSpPr/>
+      <p:sp>
+        <p:nvSpPr>
+          <p:cNvPr id="2" name="TextBox 1"/>
+          <p:cNvSpPr txBox="1"/>
+          <p:nvPr/>
+        </p:nvSpPr>
+        <p:spPr>
+          <a:xfrm>
+            <a:off x="822960" y="2651760"/>
+            <a:ext cx="10515600" cy="1645920"/>
+          </a:xfrm>
+          <a:prstGeom prst="rect">
+            <a:avLst/>
+          </a:prstGeom>
+          <a:noFill/>
+        </p:spPr>
+        <p:txBody>
+          <a:bodyPr wrap="square" anchor="ctr">
+            <a:spAutoFit/>
+          </a:bodyPr>
+          <a:lstStyle/>
+          <a:p>
+            <a:pPr algn="ctr"/>
+            <a:r>
+              <a:rPr sz="4000" b="1">
+                <a:solidFill>
+                  <a:srgbClr val="FFFFFF"/>
+                </a:solidFill>
+                <a:latin typeface="Calibri"/>
+              </a:rPr>
+              <a:t>Set clear, meaningful learning goals</a:t>
             </a:r>
           </a:p>
         </p:txBody>
@@ -3794,7 +3797,7 @@
                 </a:solidFill>
                 <a:latin typeface="Calibri"/>
               </a:rPr>
-              <a:t>SESSION 2 · CHOOSE YOUR GOAL</a:t>
+              <a:t>SESSION 1 · WHAT MAKES A GOOD GOAL</a:t>
             </a:r>
           </a:p>
         </p:txBody>
@@ -3829,7 +3832,7 @@
                 </a:solidFill>
                 <a:latin typeface="Calibri"/>
               </a:rPr>
-              <a:t>You choose what you learn</a:t>
+              <a:t>Small · Clear · It matters · By when</a:t>
             </a:r>
           </a:p>
         </p:txBody>
@@ -3890,7 +3893,7 @@
                 </a:solidFill>
                 <a:latin typeface="Calibri"/>
               </a:rPr>
-              <a:t>SESSION 2 · CHOOSE YOUR GOAL</a:t>
+              <a:t>SESSION 1 · WHAT MAKES A GOOD GOAL</a:t>
             </a:r>
           </a:p>
         </p:txBody>
@@ -3903,7 +3906,7 @@
         </p:nvSpPr>
         <p:spPr>
           <a:xfrm>
-            <a:off x="822960" y="2468880"/>
+            <a:off x="822960" y="2194560"/>
             <a:ext cx="10515600" cy="2011680"/>
           </a:xfrm>
           <a:prstGeom prst="rect">
@@ -3925,7 +3928,42 @@
                 </a:solidFill>
                 <a:latin typeface="Calibri"/>
               </a:rPr>
-              <a:t>Draw the thing you want to be able to do</a:t>
+              <a:t>A wish is big and far.</a:t>
+            </a:r>
+          </a:p>
+        </p:txBody>
+      </p:sp>
+      <p:sp>
+        <p:nvSpPr>
+          <p:cNvPr id="4" name="TextBox 3"/>
+          <p:cNvSpPr txBox="1"/>
+          <p:nvPr/>
+        </p:nvSpPr>
+        <p:spPr>
+          <a:xfrm>
+            <a:off x="822960" y="4206240"/>
+            <a:ext cx="10515600" cy="1463040"/>
+          </a:xfrm>
+          <a:prstGeom prst="rect">
+            <a:avLst/>
+          </a:prstGeom>
+          <a:noFill/>
+        </p:spPr>
+        <p:txBody>
+          <a:bodyPr wrap="square" anchor="ctr">
+            <a:spAutoFit/>
+          </a:bodyPr>
+          <a:lstStyle/>
+          <a:p>
+            <a:pPr algn="ctr"/>
+            <a:r>
+              <a:rPr sz="2600" b="0">
+                <a:solidFill>
+                  <a:srgbClr val="041E42"/>
+                </a:solidFill>
+                <a:latin typeface="Calibri"/>
+              </a:rPr>
+              <a:t>A goal is small and near, and you can tell when you reach it.</a:t>
             </a:r>
           </a:p>
         </p:txBody>
@@ -4021,7 +4059,7 @@
                 </a:solidFill>
                 <a:latin typeface="Calibri"/>
               </a:rPr>
-              <a:t>Say your goal to your partner. Make it clearer.</a:t>
+              <a:t>Judge these goals together: thumbs up or thumbs down.</a:t>
             </a:r>
           </a:p>
         </p:txBody>
@@ -4082,7 +4120,7 @@
                 </a:solidFill>
                 <a:latin typeface="Calibri"/>
               </a:rPr>
-              <a:t>SESSION 3 · YOUR FIRST STEP</a:t>
+              <a:t>SESSION 2 · CHOOSE YOUR GOAL</a:t>
             </a:r>
           </a:p>
         </p:txBody>
@@ -4117,7 +4155,7 @@
                 </a:solidFill>
                 <a:latin typeface="Calibri"/>
               </a:rPr>
-              <a:t>A big goal is easier in small steps</a:t>
+              <a:t>You choose what you learn</a:t>
             </a:r>
           </a:p>
         </p:txBody>
@@ -4178,7 +4216,7 @@
                 </a:solidFill>
                 <a:latin typeface="Calibri"/>
               </a:rPr>
-              <a:t>SESSION 3 · YOUR FIRST STEP</a:t>
+              <a:t>SESSION 2 · CHOOSE YOUR GOAL</a:t>
             </a:r>
           </a:p>
         </p:txBody>
@@ -4191,7 +4229,7 @@
         </p:nvSpPr>
         <p:spPr>
           <a:xfrm>
-            <a:off x="822960" y="2194560"/>
+            <a:off x="822960" y="2468880"/>
             <a:ext cx="10515600" cy="2011680"/>
           </a:xfrm>
           <a:prstGeom prst="rect">
@@ -4213,42 +4251,7 @@
                 </a:solidFill>
                 <a:latin typeface="Calibri"/>
               </a:rPr>
-              <a:t>What is your first step?</a:t>
-            </a:r>
-          </a:p>
-        </p:txBody>
-      </p:sp>
-      <p:sp>
-        <p:nvSpPr>
-          <p:cNvPr id="4" name="TextBox 3"/>
-          <p:cNvSpPr txBox="1"/>
-          <p:nvPr/>
-        </p:nvSpPr>
-        <p:spPr>
-          <a:xfrm>
-            <a:off x="822960" y="4206240"/>
-            <a:ext cx="10515600" cy="1463040"/>
-          </a:xfrm>
-          <a:prstGeom prst="rect">
-            <a:avLst/>
-          </a:prstGeom>
-          <a:noFill/>
-        </p:spPr>
-        <p:txBody>
-          <a:bodyPr wrap="square" anchor="ctr">
-            <a:spAutoFit/>
-          </a:bodyPr>
-          <a:lstStyle/>
-          <a:p>
-            <a:pPr algn="ctr"/>
-            <a:r>
-              <a:rPr sz="2600" b="0">
-                <a:solidFill>
-                  <a:srgbClr val="041E42"/>
-                </a:solidFill>
-                <a:latin typeface="Calibri"/>
-              </a:rPr>
-              <a:t>Small enough to take this week.</a:t>
+              <a:t>Draw the thing you want to be able to do</a:t>
             </a:r>
           </a:p>
         </p:txBody>
@@ -4309,7 +4312,7 @@
                 </a:solidFill>
                 <a:latin typeface="Calibri"/>
               </a:rPr>
-              <a:t>Understand yourself as a learner</a:t>
+              <a:t>What we will learn</a:t>
             </a:r>
           </a:p>
         </p:txBody>
@@ -4405,7 +4408,7 @@
                 </a:solidFill>
                 <a:latin typeface="Calibri"/>
               </a:rPr>
-              <a:t>Take your first step. Tell your partner when you will do it.</a:t>
+              <a:t>Say your goal to your partner. Make it clearer.</a:t>
             </a:r>
           </a:p>
         </p:txBody>
@@ -4424,7 +4427,7 @@
     <p:bg>
       <p:bgPr>
         <a:solidFill>
-          <a:srgbClr val="004976"/>
+          <a:srgbClr val="FFFFFF"/>
         </a:solidFill>
         <a:effectLst/>
       </p:bgPr>
@@ -4444,29 +4447,64 @@
         </p:nvSpPr>
         <p:spPr>
           <a:xfrm>
-            <a:off x="822960" y="2651760"/>
-            <a:ext cx="10515600" cy="1645920"/>
-          </a:xfrm>
-          <a:prstGeom prst="rect">
-            <a:avLst/>
-          </a:prstGeom>
-          <a:noFill/>
-        </p:spPr>
-        <p:txBody>
-          <a:bodyPr wrap="square" anchor="ctr">
-            <a:spAutoFit/>
-          </a:bodyPr>
-          <a:lstStyle/>
-          <a:p>
-            <a:pPr algn="ctr"/>
-            <a:r>
-              <a:rPr sz="4000" b="1">
-                <a:solidFill>
-                  <a:srgbClr val="FFFFFF"/>
-                </a:solidFill>
-                <a:latin typeface="Calibri"/>
-              </a:rPr>
-              <a:t>Plan and take deliberate steps</a:t>
+            <a:off x="822960" y="640080"/>
+            <a:ext cx="10515600" cy="457200"/>
+          </a:xfrm>
+          <a:prstGeom prst="rect">
+            <a:avLst/>
+          </a:prstGeom>
+          <a:noFill/>
+        </p:spPr>
+        <p:txBody>
+          <a:bodyPr wrap="square" anchor="ctr">
+            <a:spAutoFit/>
+          </a:bodyPr>
+          <a:lstStyle/>
+          <a:p>
+            <a:pPr algn="ctr"/>
+            <a:r>
+              <a:rPr sz="1500" b="1" spc="300">
+                <a:solidFill>
+                  <a:srgbClr val="EF9600"/>
+                </a:solidFill>
+                <a:latin typeface="Calibri"/>
+              </a:rPr>
+              <a:t>SESSION 3 · YOUR FIRST STEP</a:t>
+            </a:r>
+          </a:p>
+        </p:txBody>
+      </p:sp>
+      <p:sp>
+        <p:nvSpPr>
+          <p:cNvPr id="3" name="TextBox 2"/>
+          <p:cNvSpPr txBox="1"/>
+          <p:nvPr/>
+        </p:nvSpPr>
+        <p:spPr>
+          <a:xfrm>
+            <a:off x="822960" y="2468880"/>
+            <a:ext cx="10515600" cy="2011680"/>
+          </a:xfrm>
+          <a:prstGeom prst="rect">
+            <a:avLst/>
+          </a:prstGeom>
+          <a:noFill/>
+        </p:spPr>
+        <p:txBody>
+          <a:bodyPr wrap="square" anchor="ctr">
+            <a:spAutoFit/>
+          </a:bodyPr>
+          <a:lstStyle/>
+          <a:p>
+            <a:pPr algn="ctr"/>
+            <a:r>
+              <a:rPr sz="4600" b="1">
+                <a:solidFill>
+                  <a:srgbClr val="004976"/>
+                </a:solidFill>
+                <a:latin typeface="Calibri"/>
+              </a:rPr>
+              <a:t>A big goal is easier in small steps</a:t>
             </a:r>
           </a:p>
         </p:txBody>
@@ -4527,7 +4565,7 @@
                 </a:solidFill>
                 <a:latin typeface="Calibri"/>
               </a:rPr>
-              <a:t>SESSION 1 · MAKE AN ACTION PLAN</a:t>
+              <a:t>SESSION 3 · YOUR FIRST STEP</a:t>
             </a:r>
           </a:p>
         </p:txBody>
@@ -4540,7 +4578,7 @@
         </p:nvSpPr>
         <p:spPr>
           <a:xfrm>
-            <a:off x="822960" y="2468880"/>
+            <a:off x="822960" y="2194560"/>
             <a:ext cx="10515600" cy="2011680"/>
           </a:xfrm>
           <a:prstGeom prst="rect">
@@ -4562,7 +4600,42 @@
                 </a:solidFill>
                 <a:latin typeface="Calibri"/>
               </a:rPr>
-              <a:t>Break your goal into steps you can do</a:t>
+              <a:t>What is your first step?</a:t>
+            </a:r>
+          </a:p>
+        </p:txBody>
+      </p:sp>
+      <p:sp>
+        <p:nvSpPr>
+          <p:cNvPr id="4" name="TextBox 3"/>
+          <p:cNvSpPr txBox="1"/>
+          <p:nvPr/>
+        </p:nvSpPr>
+        <p:spPr>
+          <a:xfrm>
+            <a:off x="822960" y="4206240"/>
+            <a:ext cx="10515600" cy="1463040"/>
+          </a:xfrm>
+          <a:prstGeom prst="rect">
+            <a:avLst/>
+          </a:prstGeom>
+          <a:noFill/>
+        </p:spPr>
+        <p:txBody>
+          <a:bodyPr wrap="square" anchor="ctr">
+            <a:spAutoFit/>
+          </a:bodyPr>
+          <a:lstStyle/>
+          <a:p>
+            <a:pPr algn="ctr"/>
+            <a:r>
+              <a:rPr sz="2600" b="0">
+                <a:solidFill>
+                  <a:srgbClr val="041E42"/>
+                </a:solidFill>
+                <a:latin typeface="Calibri"/>
+              </a:rPr>
+              <a:t>Small enough to take this week.</a:t>
             </a:r>
           </a:p>
         </p:txBody>
@@ -4658,7 +4731,7 @@
                 </a:solidFill>
                 <a:latin typeface="Calibri"/>
               </a:rPr>
-              <a:t>Draw your plan. What comes first?</a:t>
+              <a:t>Take your first step. Tell your partner when you will do it.</a:t>
             </a:r>
           </a:p>
         </p:txBody>
@@ -4672,6 +4745,67 @@
 </file>
 
 <file path=ppt/slides/slide24.xml><?xml version="1.0" encoding="utf-8"?>
+<p:sld xmlns:a="http://schemas.openxmlformats.org/drawingml/2006/main" xmlns:p="http://schemas.openxmlformats.org/presentationml/2006/main" xmlns:r="http://schemas.openxmlformats.org/officeDocument/2006/relationships">
+  <p:cSld>
+    <p:bg>
+      <p:bgPr>
+        <a:solidFill>
+          <a:srgbClr val="004976"/>
+        </a:solidFill>
+        <a:effectLst/>
+      </p:bgPr>
+    </p:bg>
+    <p:spTree>
+      <p:nvGrpSpPr>
+        <p:cNvPr id="1" name=""/>
+        <p:cNvGrpSpPr/>
+        <p:nvPr/>
+      </p:nvGrpSpPr>
+      <p:grpSpPr/>
+      <p:sp>
+        <p:nvSpPr>
+          <p:cNvPr id="2" name="TextBox 1"/>
+          <p:cNvSpPr txBox="1"/>
+          <p:nvPr/>
+        </p:nvSpPr>
+        <p:spPr>
+          <a:xfrm>
+            <a:off x="822960" y="2651760"/>
+            <a:ext cx="10515600" cy="1645920"/>
+          </a:xfrm>
+          <a:prstGeom prst="rect">
+            <a:avLst/>
+          </a:prstGeom>
+          <a:noFill/>
+        </p:spPr>
+        <p:txBody>
+          <a:bodyPr wrap="square" anchor="ctr">
+            <a:spAutoFit/>
+          </a:bodyPr>
+          <a:lstStyle/>
+          <a:p>
+            <a:pPr algn="ctr"/>
+            <a:r>
+              <a:rPr sz="4000" b="1">
+                <a:solidFill>
+                  <a:srgbClr val="FFFFFF"/>
+                </a:solidFill>
+                <a:latin typeface="Calibri"/>
+              </a:rPr>
+              <a:t>Plan and take deliberate steps</a:t>
+            </a:r>
+          </a:p>
+        </p:txBody>
+      </p:sp>
+    </p:spTree>
+  </p:cSld>
+  <p:clrMapOvr>
+    <a:masterClrMapping/>
+  </p:clrMapOvr>
+</p:sld>
+</file>
+
+<file path=ppt/slides/slide25.xml><?xml version="1.0" encoding="utf-8"?>
 <p:sld xmlns:a="http://schemas.openxmlformats.org/drawingml/2006/main" xmlns:p="http://schemas.openxmlformats.org/presentationml/2006/main" xmlns:r="http://schemas.openxmlformats.org/officeDocument/2006/relationships">
   <p:cSld>
     <p:bg>
@@ -4719,7 +4853,7 @@
                 </a:solidFill>
                 <a:latin typeface="Calibri"/>
               </a:rPr>
-              <a:t>SESSION 2 · MANAGE YOUR TIME</a:t>
+              <a:t>SESSION 1 · MAKE AN ACTION PLAN</a:t>
             </a:r>
           </a:p>
         </p:txBody>
@@ -4754,7 +4888,7 @@
                 </a:solidFill>
                 <a:latin typeface="Calibri"/>
               </a:rPr>
-              <a:t>Do the most important thing first</a:t>
+              <a:t>Break your goal into steps you can do</a:t>
             </a:r>
           </a:p>
         </p:txBody>
@@ -4767,7 +4901,7 @@
 </p:sld>
 </file>
 
-<file path=ppt/slides/slide25.xml><?xml version="1.0" encoding="utf-8"?>
+<file path=ppt/slides/slide26.xml><?xml version="1.0" encoding="utf-8"?>
 <p:sld xmlns:a="http://schemas.openxmlformats.org/drawingml/2006/main" xmlns:p="http://schemas.openxmlformats.org/presentationml/2006/main" xmlns:r="http://schemas.openxmlformats.org/officeDocument/2006/relationships">
   <p:cSld>
     <p:bg>
@@ -4850,7 +4984,7 @@
                 </a:solidFill>
                 <a:latin typeface="Calibri"/>
               </a:rPr>
-              <a:t>This week, do your learning thing before the easy things.</a:t>
+              <a:t>Draw your plan. What comes first?</a:t>
             </a:r>
           </a:p>
         </p:txBody>
@@ -4863,7 +4997,7 @@
 </p:sld>
 </file>
 
-<file path=ppt/slides/slide26.xml><?xml version="1.0" encoding="utf-8"?>
+<file path=ppt/slides/slide27.xml><?xml version="1.0" encoding="utf-8"?>
 <p:sld xmlns:a="http://schemas.openxmlformats.org/drawingml/2006/main" xmlns:p="http://schemas.openxmlformats.org/presentationml/2006/main" xmlns:r="http://schemas.openxmlformats.org/officeDocument/2006/relationships">
   <p:cSld>
     <p:bg>
@@ -4911,7 +5045,7 @@
                 </a:solidFill>
                 <a:latin typeface="Calibri"/>
               </a:rPr>
-              <a:t>SESSION 3 · FIND HELP</a:t>
+              <a:t>SESSION 2 · MANAGE YOUR TIME</a:t>
             </a:r>
           </a:p>
         </p:txBody>
@@ -4946,7 +5080,7 @@
                 </a:solidFill>
                 <a:latin typeface="Calibri"/>
               </a:rPr>
-              <a:t>Who can help you? What do you need?</a:t>
+              <a:t>Do the most important thing first</a:t>
             </a:r>
           </a:p>
         </p:txBody>
@@ -4959,7 +5093,7 @@
 </p:sld>
 </file>
 
-<file path=ppt/slides/slide27.xml><?xml version="1.0" encoding="utf-8"?>
+<file path=ppt/slides/slide28.xml><?xml version="1.0" encoding="utf-8"?>
 <p:sld xmlns:a="http://schemas.openxmlformats.org/drawingml/2006/main" xmlns:p="http://schemas.openxmlformats.org/presentationml/2006/main" xmlns:r="http://schemas.openxmlformats.org/officeDocument/2006/relationships">
   <p:cSld>
     <p:bg>
@@ -5042,68 +5176,7 @@
                 </a:solidFill>
                 <a:latin typeface="Calibri"/>
               </a:rPr>
-              <a:t>Ask one person for help. Then use it.</a:t>
-            </a:r>
-          </a:p>
-        </p:txBody>
-      </p:sp>
-    </p:spTree>
-  </p:cSld>
-  <p:clrMapOvr>
-    <a:masterClrMapping/>
-  </p:clrMapOvr>
-</p:sld>
-</file>
-
-<file path=ppt/slides/slide28.xml><?xml version="1.0" encoding="utf-8"?>
-<p:sld xmlns:a="http://schemas.openxmlformats.org/drawingml/2006/main" xmlns:p="http://schemas.openxmlformats.org/presentationml/2006/main" xmlns:r="http://schemas.openxmlformats.org/officeDocument/2006/relationships">
-  <p:cSld>
-    <p:bg>
-      <p:bgPr>
-        <a:solidFill>
-          <a:srgbClr val="004976"/>
-        </a:solidFill>
-        <a:effectLst/>
-      </p:bgPr>
-    </p:bg>
-    <p:spTree>
-      <p:nvGrpSpPr>
-        <p:cNvPr id="1" name=""/>
-        <p:cNvGrpSpPr/>
-        <p:nvPr/>
-      </p:nvGrpSpPr>
-      <p:grpSpPr/>
-      <p:sp>
-        <p:nvSpPr>
-          <p:cNvPr id="2" name="TextBox 1"/>
-          <p:cNvSpPr txBox="1"/>
-          <p:nvPr/>
-        </p:nvSpPr>
-        <p:spPr>
-          <a:xfrm>
-            <a:off x="822960" y="2651760"/>
-            <a:ext cx="10515600" cy="1645920"/>
-          </a:xfrm>
-          <a:prstGeom prst="rect">
-            <a:avLst/>
-          </a:prstGeom>
-          <a:noFill/>
-        </p:spPr>
-        <p:txBody>
-          <a:bodyPr wrap="square" anchor="ctr">
-            <a:spAutoFit/>
-          </a:bodyPr>
-          <a:lstStyle/>
-          <a:p>
-            <a:pPr algn="ctr"/>
-            <a:r>
-              <a:rPr sz="4000" b="1">
-                <a:solidFill>
-                  <a:srgbClr val="FFFFFF"/>
-                </a:solidFill>
-                <a:latin typeface="Calibri"/>
-              </a:rPr>
-              <a:t>Track, feedback, and reflect</a:t>
+              <a:t>This week, do your learning thing before the easy things.</a:t>
             </a:r>
           </a:p>
         </p:txBody>
@@ -5164,7 +5237,7 @@
                 </a:solidFill>
                 <a:latin typeface="Calibri"/>
               </a:rPr>
-              <a:t>SESSION 1 · KEEP YOUR LEARNING BOOK</a:t>
+              <a:t>SESSION 3 · FIND HELP</a:t>
             </a:r>
           </a:p>
         </p:txBody>
@@ -5199,7 +5272,7 @@
                 </a:solidFill>
                 <a:latin typeface="Calibri"/>
               </a:rPr>
-              <a:t>One small mark keeps your learning visible</a:t>
+              <a:t>Who can help you? What do you need?</a:t>
             </a:r>
           </a:p>
         </p:txBody>
@@ -5260,7 +5333,7 @@
                 </a:solidFill>
                 <a:latin typeface="Calibri"/>
               </a:rPr>
-              <a:t>SESSION 1 · YOU CAN GROW</a:t>
+              <a:t>OUR LEARNING JOURNEY</a:t>
             </a:r>
           </a:p>
         </p:txBody>
@@ -5295,7 +5368,7 @@
                 </a:solidFill>
                 <a:latin typeface="Calibri"/>
               </a:rPr>
-              <a:t>You can grow</a:t>
+              <a:t>Four steps</a:t>
             </a:r>
           </a:p>
         </p:txBody>
@@ -5330,7 +5403,7 @@
                 </a:solidFill>
                 <a:latin typeface="Calibri"/>
               </a:rPr>
-              <a:t>Everyone gets better with practice, a new way, and help.</a:t>
+              <a:t>Know yourself · Set a goal · Make a plan · See how you grow</a:t>
             </a:r>
           </a:p>
         </p:txBody>
@@ -5426,7 +5499,7 @@
                 </a:solidFill>
                 <a:latin typeface="Calibri"/>
               </a:rPr>
-              <a:t>Make one mark or drawing after each session.</a:t>
+              <a:t>Ask one person for help. Then use it.</a:t>
             </a:r>
           </a:p>
         </p:txBody>
@@ -5440,6 +5513,67 @@
 </file>
 
 <file path=ppt/slides/slide31.xml><?xml version="1.0" encoding="utf-8"?>
+<p:sld xmlns:a="http://schemas.openxmlformats.org/drawingml/2006/main" xmlns:p="http://schemas.openxmlformats.org/presentationml/2006/main" xmlns:r="http://schemas.openxmlformats.org/officeDocument/2006/relationships">
+  <p:cSld>
+    <p:bg>
+      <p:bgPr>
+        <a:solidFill>
+          <a:srgbClr val="004976"/>
+        </a:solidFill>
+        <a:effectLst/>
+      </p:bgPr>
+    </p:bg>
+    <p:spTree>
+      <p:nvGrpSpPr>
+        <p:cNvPr id="1" name=""/>
+        <p:cNvGrpSpPr/>
+        <p:nvPr/>
+      </p:nvGrpSpPr>
+      <p:grpSpPr/>
+      <p:sp>
+        <p:nvSpPr>
+          <p:cNvPr id="2" name="TextBox 1"/>
+          <p:cNvSpPr txBox="1"/>
+          <p:nvPr/>
+        </p:nvSpPr>
+        <p:spPr>
+          <a:xfrm>
+            <a:off x="822960" y="2651760"/>
+            <a:ext cx="10515600" cy="1645920"/>
+          </a:xfrm>
+          <a:prstGeom prst="rect">
+            <a:avLst/>
+          </a:prstGeom>
+          <a:noFill/>
+        </p:spPr>
+        <p:txBody>
+          <a:bodyPr wrap="square" anchor="ctr">
+            <a:spAutoFit/>
+          </a:bodyPr>
+          <a:lstStyle/>
+          <a:p>
+            <a:pPr algn="ctr"/>
+            <a:r>
+              <a:rPr sz="4000" b="1">
+                <a:solidFill>
+                  <a:srgbClr val="FFFFFF"/>
+                </a:solidFill>
+                <a:latin typeface="Calibri"/>
+              </a:rPr>
+              <a:t>Track, feedback, and reflect</a:t>
+            </a:r>
+          </a:p>
+        </p:txBody>
+      </p:sp>
+    </p:spTree>
+  </p:cSld>
+  <p:clrMapOvr>
+    <a:masterClrMapping/>
+  </p:clrMapOvr>
+</p:sld>
+</file>
+
+<file path=ppt/slides/slide32.xml><?xml version="1.0" encoding="utf-8"?>
 <p:sld xmlns:a="http://schemas.openxmlformats.org/drawingml/2006/main" xmlns:p="http://schemas.openxmlformats.org/presentationml/2006/main" xmlns:r="http://schemas.openxmlformats.org/officeDocument/2006/relationships">
   <p:cSld>
     <p:bg>
@@ -5487,7 +5621,7 @@
                 </a:solidFill>
                 <a:latin typeface="Calibri"/>
               </a:rPr>
-              <a:t>SESSION 2 · FEEDBACK</a:t>
+              <a:t>SESSION 1 · KEEP YOUR LEARNING BOOK</a:t>
             </a:r>
           </a:p>
         </p:txBody>
@@ -5522,7 +5656,7 @@
                 </a:solidFill>
                 <a:latin typeface="Calibri"/>
               </a:rPr>
-              <a:t>Ask: what is one thing I could do better?</a:t>
+              <a:t>One small mark keeps your learning visible</a:t>
             </a:r>
           </a:p>
         </p:txBody>
@@ -5535,7 +5669,7 @@
 </p:sld>
 </file>
 
-<file path=ppt/slides/slide32.xml><?xml version="1.0" encoding="utf-8"?>
+<file path=ppt/slides/slide33.xml><?xml version="1.0" encoding="utf-8"?>
 <p:sld xmlns:a="http://schemas.openxmlformats.org/drawingml/2006/main" xmlns:p="http://schemas.openxmlformats.org/presentationml/2006/main" xmlns:r="http://schemas.openxmlformats.org/officeDocument/2006/relationships">
   <p:cSld>
     <p:bg>
@@ -5618,7 +5752,7 @@
                 </a:solidFill>
                 <a:latin typeface="Calibri"/>
               </a:rPr>
-              <a:t>Ask one person. Then try what they say.</a:t>
+              <a:t>Make one mark or drawing after each session.</a:t>
             </a:r>
           </a:p>
         </p:txBody>
@@ -5631,7 +5765,7 @@
 </p:sld>
 </file>
 
-<file path=ppt/slides/slide33.xml><?xml version="1.0" encoding="utf-8"?>
+<file path=ppt/slides/slide34.xml><?xml version="1.0" encoding="utf-8"?>
 <p:sld xmlns:a="http://schemas.openxmlformats.org/drawingml/2006/main" xmlns:p="http://schemas.openxmlformats.org/presentationml/2006/main" xmlns:r="http://schemas.openxmlformats.org/officeDocument/2006/relationships">
   <p:cSld>
     <p:bg>
@@ -5679,7 +5813,7 @@
                 </a:solidFill>
                 <a:latin typeface="Calibri"/>
               </a:rPr>
-              <a:t>SESSION 3 · REFLECT</a:t>
+              <a:t>SESSION 2 · FEEDBACK</a:t>
             </a:r>
           </a:p>
         </p:txBody>
@@ -5714,7 +5848,7 @@
                 </a:solidFill>
                 <a:latin typeface="Calibri"/>
               </a:rPr>
-              <a:t>Look how far you have come</a:t>
+              <a:t>Ask: what is one thing I could do better?</a:t>
             </a:r>
           </a:p>
         </p:txBody>
@@ -5727,7 +5861,7 @@
 </p:sld>
 </file>
 
-<file path=ppt/slides/slide34.xml><?xml version="1.0" encoding="utf-8"?>
+<file path=ppt/slides/slide35.xml><?xml version="1.0" encoding="utf-8"?>
 <p:sld xmlns:a="http://schemas.openxmlformats.org/drawingml/2006/main" xmlns:p="http://schemas.openxmlformats.org/presentationml/2006/main" xmlns:r="http://schemas.openxmlformats.org/officeDocument/2006/relationships">
   <p:cSld>
     <p:bg>
@@ -5810,7 +5944,7 @@
                 </a:solidFill>
                 <a:latin typeface="Calibri"/>
               </a:rPr>
-              <a:t>Find one way you have grown. Be ready to share it.</a:t>
+              <a:t>Ask one person. Then try what they say.</a:t>
             </a:r>
           </a:p>
         </p:txBody>
@@ -5823,7 +5957,7 @@
 </p:sld>
 </file>
 
-<file path=ppt/slides/slide4.xml><?xml version="1.0" encoding="utf-8"?>
+<file path=ppt/slides/slide36.xml><?xml version="1.0" encoding="utf-8"?>
 <p:sld xmlns:a="http://schemas.openxmlformats.org/drawingml/2006/main" xmlns:p="http://schemas.openxmlformats.org/presentationml/2006/main" xmlns:r="http://schemas.openxmlformats.org/officeDocument/2006/relationships">
   <p:cSld>
     <p:bg>
@@ -5871,7 +6005,7 @@
                 </a:solidFill>
                 <a:latin typeface="Calibri"/>
               </a:rPr>
-              <a:t>SESSION 1 · YOU CAN GROW</a:t>
+              <a:t>SESSION 3 · REFLECT</a:t>
             </a:r>
           </a:p>
         </p:txBody>
@@ -5906,7 +6040,7 @@
                 </a:solidFill>
                 <a:latin typeface="Calibri"/>
               </a:rPr>
-              <a:t>I cannot do this… yet</a:t>
+              <a:t>Look how far you have come</a:t>
             </a:r>
           </a:p>
         </p:txBody>
@@ -5919,7 +6053,7 @@
 </p:sld>
 </file>
 
-<file path=ppt/slides/slide5.xml><?xml version="1.0" encoding="utf-8"?>
+<file path=ppt/slides/slide37.xml><?xml version="1.0" encoding="utf-8"?>
 <p:sld xmlns:a="http://schemas.openxmlformats.org/drawingml/2006/main" xmlns:p="http://schemas.openxmlformats.org/presentationml/2006/main" xmlns:r="http://schemas.openxmlformats.org/officeDocument/2006/relationships">
   <p:cSld>
     <p:bg>
@@ -6002,7 +6136,164 @@
                 </a:solidFill>
                 <a:latin typeface="Calibri"/>
               </a:rPr>
-              <a:t>Draw a time you got better at something that was hard.</a:t>
+              <a:t>Find one way you have grown. Be ready to share it.</a:t>
+            </a:r>
+          </a:p>
+        </p:txBody>
+      </p:sp>
+    </p:spTree>
+  </p:cSld>
+  <p:clrMapOvr>
+    <a:masterClrMapping/>
+  </p:clrMapOvr>
+</p:sld>
+</file>
+
+<file path=ppt/slides/slide4.xml><?xml version="1.0" encoding="utf-8"?>
+<p:sld xmlns:a="http://schemas.openxmlformats.org/drawingml/2006/main" xmlns:p="http://schemas.openxmlformats.org/presentationml/2006/main" xmlns:r="http://schemas.openxmlformats.org/officeDocument/2006/relationships">
+  <p:cSld>
+    <p:bg>
+      <p:bgPr>
+        <a:solidFill>
+          <a:srgbClr val="E1EEF1"/>
+        </a:solidFill>
+        <a:effectLst/>
+      </p:bgPr>
+    </p:bg>
+    <p:spTree>
+      <p:nvGrpSpPr>
+        <p:cNvPr id="1" name=""/>
+        <p:cNvGrpSpPr/>
+        <p:nvPr/>
+      </p:nvGrpSpPr>
+      <p:grpSpPr/>
+      <p:sp>
+        <p:nvSpPr>
+          <p:cNvPr id="2" name="TextBox 1"/>
+          <p:cNvSpPr txBox="1"/>
+          <p:nvPr/>
+        </p:nvSpPr>
+        <p:spPr>
+          <a:xfrm>
+            <a:off x="822960" y="822960"/>
+            <a:ext cx="10515600" cy="457200"/>
+          </a:xfrm>
+          <a:prstGeom prst="rect">
+            <a:avLst/>
+          </a:prstGeom>
+          <a:noFill/>
+        </p:spPr>
+        <p:txBody>
+          <a:bodyPr wrap="square" anchor="ctr">
+            <a:spAutoFit/>
+          </a:bodyPr>
+          <a:lstStyle/>
+          <a:p>
+            <a:pPr algn="ctr"/>
+            <a:r>
+              <a:rPr sz="1600" b="1" spc="300">
+                <a:solidFill>
+                  <a:srgbClr val="3F8291"/>
+                </a:solidFill>
+                <a:latin typeface="Calibri"/>
+              </a:rPr>
+              <a:t>DO</a:t>
+            </a:r>
+          </a:p>
+        </p:txBody>
+      </p:sp>
+      <p:sp>
+        <p:nvSpPr>
+          <p:cNvPr id="3" name="TextBox 2"/>
+          <p:cNvSpPr txBox="1"/>
+          <p:nvPr/>
+        </p:nvSpPr>
+        <p:spPr>
+          <a:xfrm>
+            <a:off x="822960" y="2560320"/>
+            <a:ext cx="10515600" cy="1828800"/>
+          </a:xfrm>
+          <a:prstGeom prst="rect">
+            <a:avLst/>
+          </a:prstGeom>
+          <a:noFill/>
+        </p:spPr>
+        <p:txBody>
+          <a:bodyPr wrap="square" anchor="ctr">
+            <a:spAutoFit/>
+          </a:bodyPr>
+          <a:lstStyle/>
+          <a:p>
+            <a:pPr algn="ctr"/>
+            <a:r>
+              <a:rPr sz="4000" b="1">
+                <a:solidFill>
+                  <a:srgbClr val="041E42"/>
+                </a:solidFill>
+                <a:latin typeface="Calibri"/>
+              </a:rPr>
+              <a:t>How would you try each one? Tell us what you already do.</a:t>
+            </a:r>
+          </a:p>
+        </p:txBody>
+      </p:sp>
+    </p:spTree>
+  </p:cSld>
+  <p:clrMapOvr>
+    <a:masterClrMapping/>
+  </p:clrMapOvr>
+</p:sld>
+</file>
+
+<file path=ppt/slides/slide5.xml><?xml version="1.0" encoding="utf-8"?>
+<p:sld xmlns:a="http://schemas.openxmlformats.org/drawingml/2006/main" xmlns:p="http://schemas.openxmlformats.org/presentationml/2006/main" xmlns:r="http://schemas.openxmlformats.org/officeDocument/2006/relationships">
+  <p:cSld>
+    <p:bg>
+      <p:bgPr>
+        <a:solidFill>
+          <a:srgbClr val="004976"/>
+        </a:solidFill>
+        <a:effectLst/>
+      </p:bgPr>
+    </p:bg>
+    <p:spTree>
+      <p:nvGrpSpPr>
+        <p:cNvPr id="1" name=""/>
+        <p:cNvGrpSpPr/>
+        <p:nvPr/>
+      </p:nvGrpSpPr>
+      <p:grpSpPr/>
+      <p:sp>
+        <p:nvSpPr>
+          <p:cNvPr id="2" name="TextBox 1"/>
+          <p:cNvSpPr txBox="1"/>
+          <p:nvPr/>
+        </p:nvSpPr>
+        <p:spPr>
+          <a:xfrm>
+            <a:off x="822960" y="2651760"/>
+            <a:ext cx="10515600" cy="1645920"/>
+          </a:xfrm>
+          <a:prstGeom prst="rect">
+            <a:avLst/>
+          </a:prstGeom>
+          <a:noFill/>
+        </p:spPr>
+        <p:txBody>
+          <a:bodyPr wrap="square" anchor="ctr">
+            <a:spAutoFit/>
+          </a:bodyPr>
+          <a:lstStyle/>
+          <a:p>
+            <a:pPr algn="ctr"/>
+            <a:r>
+              <a:rPr sz="4000" b="1">
+                <a:solidFill>
+                  <a:srgbClr val="FFFFFF"/>
+                </a:solidFill>
+                <a:latin typeface="Calibri"/>
+              </a:rPr>
+              <a:t>Understand yourself as a learner</a:t>
             </a:r>
           </a:p>
         </p:txBody>
@@ -6063,7 +6354,7 @@
                 </a:solidFill>
                 <a:latin typeface="Calibri"/>
               </a:rPr>
-              <a:t>SESSION 2 · WHAT I AM GOOD AT</a:t>
+              <a:t>SESSION 1 · YOU CAN GROW</a:t>
             </a:r>
           </a:p>
         </p:txBody>
@@ -6076,7 +6367,7 @@
         </p:nvSpPr>
         <p:spPr>
           <a:xfrm>
-            <a:off x="822960" y="2468880"/>
+            <a:off x="822960" y="2194560"/>
             <a:ext cx="10515600" cy="2011680"/>
           </a:xfrm>
           <a:prstGeom prst="rect">
@@ -6098,7 +6389,42 @@
                 </a:solidFill>
                 <a:latin typeface="Calibri"/>
               </a:rPr>
-              <a:t>What am I good at as a learner?</a:t>
+              <a:t>You can grow</a:t>
+            </a:r>
+          </a:p>
+        </p:txBody>
+      </p:sp>
+      <p:sp>
+        <p:nvSpPr>
+          <p:cNvPr id="4" name="TextBox 3"/>
+          <p:cNvSpPr txBox="1"/>
+          <p:nvPr/>
+        </p:nvSpPr>
+        <p:spPr>
+          <a:xfrm>
+            <a:off x="822960" y="4206240"/>
+            <a:ext cx="10515600" cy="1463040"/>
+          </a:xfrm>
+          <a:prstGeom prst="rect">
+            <a:avLst/>
+          </a:prstGeom>
+          <a:noFill/>
+        </p:spPr>
+        <p:txBody>
+          <a:bodyPr wrap="square" anchor="ctr">
+            <a:spAutoFit/>
+          </a:bodyPr>
+          <a:lstStyle/>
+          <a:p>
+            <a:pPr algn="ctr"/>
+            <a:r>
+              <a:rPr sz="2600" b="0">
+                <a:solidFill>
+                  <a:srgbClr val="041E42"/>
+                </a:solidFill>
+                <a:latin typeface="Calibri"/>
+              </a:rPr>
+              <a:t>Everyone gets better with practice, a new way, and help.</a:t>
             </a:r>
           </a:p>
         </p:txBody>
@@ -6159,7 +6485,7 @@
                 </a:solidFill>
                 <a:latin typeface="Calibri"/>
               </a:rPr>
-              <a:t>SESSION 2 · WHAT I WANT TO GROW</a:t>
+              <a:t>SESSION 1 · YOU CAN GROW</a:t>
             </a:r>
           </a:p>
         </p:txBody>
@@ -6194,7 +6520,7 @@
                 </a:solidFill>
                 <a:latin typeface="Calibri"/>
               </a:rPr>
-              <a:t>What do I want to grow?</a:t>
+              <a:t>I cannot do this… yet</a:t>
             </a:r>
           </a:p>
         </p:txBody>
@@ -6290,7 +6616,7 @@
                 </a:solidFill>
                 <a:latin typeface="Calibri"/>
               </a:rPr>
-              <a:t>Draw your strengths. Hear what others see in you.</a:t>
+              <a:t>Draw a time you got better at something that was hard.</a:t>
             </a:r>
           </a:p>
         </p:txBody>
@@ -6351,7 +6677,7 @@
                 </a:solidFill>
                 <a:latin typeface="Calibri"/>
               </a:rPr>
-              <a:t>SESSION 3 · HOW I LEARN BEST</a:t>
+              <a:t>SESSION 2 · WHAT I AM GOOD AT</a:t>
             </a:r>
           </a:p>
         </p:txBody>
@@ -6364,7 +6690,7 @@
         </p:nvSpPr>
         <p:spPr>
           <a:xfrm>
-            <a:off x="822960" y="2194560"/>
+            <a:off x="822960" y="2468880"/>
             <a:ext cx="10515600" cy="2011680"/>
           </a:xfrm>
           <a:prstGeom prst="rect">
@@ -6386,42 +6712,7 @@
                 </a:solidFill>
                 <a:latin typeface="Calibri"/>
               </a:rPr>
-              <a:t>How do I learn best?</a:t>
-            </a:r>
-          </a:p>
-        </p:txBody>
-      </p:sp>
-      <p:sp>
-        <p:nvSpPr>
-          <p:cNvPr id="4" name="TextBox 3"/>
-          <p:cNvSpPr txBox="1"/>
-          <p:nvPr/>
-        </p:nvSpPr>
-        <p:spPr>
-          <a:xfrm>
-            <a:off x="822960" y="4206240"/>
-            <a:ext cx="10515600" cy="1463040"/>
-          </a:xfrm>
-          <a:prstGeom prst="rect">
-            <a:avLst/>
-          </a:prstGeom>
-          <a:noFill/>
-        </p:spPr>
-        <p:txBody>
-          <a:bodyPr wrap="square" anchor="ctr">
-            <a:spAutoFit/>
-          </a:bodyPr>
-          <a:lstStyle/>
-          <a:p>
-            <a:pPr algn="ctr"/>
-            <a:r>
-              <a:rPr sz="2600" b="0">
-                <a:solidFill>
-                  <a:srgbClr val="041E42"/>
-                </a:solidFill>
-                <a:latin typeface="Calibri"/>
-              </a:rPr>
-              <a:t>When? Where? Who and what helps me?</a:t>
+              <a:t>What am I good at as a learner?</a:t>
             </a:r>
           </a:p>
         </p:txBody>

</xml_diff>

<commit_message>
feat: provide the pictures the activities suggest (Picture Cards + embedded icons)
- 19 clean brand SVG icons in public/diagrams/ail/ for every image the AIL
  materials call for: the four objectives, the goal tests, strengths prompts,
  when-I-learn times, and a wish/step/feedback set.
- New editable/printable "Picture Cards" PDF download: every suggested picture
  as a labelled, cut-out card, grouped by activity.
- Embedded the four objective icons in the workbook "What we will learn" page
  and the slides, and the time icons on the how-I-learn page.
- Updated the materials that suggest pictures to point at the provided pack, so
  facilitators are given the images rather than told to source them.

Co-Authored-By: Claude Opus 4.8 <noreply@anthropic.com>
</commit_message>
<xml_diff>
--- a/public/downloads/agency-in-learning-slides.pptx
+++ b/public/downloads/agency-in-learning-slides.pptx
@@ -5333,77 +5333,243 @@
                 </a:solidFill>
                 <a:latin typeface="Calibri"/>
               </a:rPr>
-              <a:t>OUR LEARNING JOURNEY</a:t>
-            </a:r>
-          </a:p>
-        </p:txBody>
-      </p:sp>
-      <p:sp>
-        <p:nvSpPr>
-          <p:cNvPr id="3" name="TextBox 2"/>
-          <p:cNvSpPr txBox="1"/>
-          <p:nvPr/>
-        </p:nvSpPr>
-        <p:spPr>
-          <a:xfrm>
-            <a:off x="822960" y="2194560"/>
-            <a:ext cx="10515600" cy="2011680"/>
-          </a:xfrm>
-          <a:prstGeom prst="rect">
-            <a:avLst/>
-          </a:prstGeom>
-          <a:noFill/>
-        </p:spPr>
-        <p:txBody>
-          <a:bodyPr wrap="square" anchor="ctr">
-            <a:spAutoFit/>
-          </a:bodyPr>
-          <a:lstStyle/>
-          <a:p>
-            <a:pPr algn="ctr"/>
-            <a:r>
-              <a:rPr sz="4600" b="1">
+              <a:t>OUR FOUR STEPS</a:t>
+            </a:r>
+          </a:p>
+        </p:txBody>
+      </p:sp>
+      <p:pic>
+        <p:nvPicPr>
+          <p:cNvPr id="3" name="Picture 2" descr="obj-know-yourself.png"/>
+          <p:cNvPicPr>
+            <a:picLocks noChangeAspect="1"/>
+          </p:cNvPicPr>
+          <p:nvPr/>
+        </p:nvPicPr>
+        <p:blipFill>
+          <a:blip r:embed="rId2"/>
+          <a:stretch>
+            <a:fillRect/>
+          </a:stretch>
+        </p:blipFill>
+        <p:spPr>
+          <a:xfrm>
+            <a:off x="1121603" y="2286000"/>
+            <a:ext cx="1645920" cy="1645920"/>
+          </a:xfrm>
+          <a:prstGeom prst="rect">
+            <a:avLst/>
+          </a:prstGeom>
+        </p:spPr>
+      </p:pic>
+      <p:sp>
+        <p:nvSpPr>
+          <p:cNvPr id="4" name="TextBox 3"/>
+          <p:cNvSpPr txBox="1"/>
+          <p:nvPr/>
+        </p:nvSpPr>
+        <p:spPr>
+          <a:xfrm>
+            <a:off x="847283" y="4023359"/>
+            <a:ext cx="2194560" cy="822960"/>
+          </a:xfrm>
+          <a:prstGeom prst="rect">
+            <a:avLst/>
+          </a:prstGeom>
+          <a:noFill/>
+        </p:spPr>
+        <p:txBody>
+          <a:bodyPr wrap="square" anchor="ctr">
+            <a:spAutoFit/>
+          </a:bodyPr>
+          <a:lstStyle/>
+          <a:p>
+            <a:pPr algn="ctr"/>
+            <a:r>
+              <a:rPr sz="1700" b="1">
                 <a:solidFill>
                   <a:srgbClr val="004976"/>
                 </a:solidFill>
                 <a:latin typeface="Calibri"/>
               </a:rPr>
-              <a:t>Four steps</a:t>
-            </a:r>
-          </a:p>
-        </p:txBody>
-      </p:sp>
-      <p:sp>
-        <p:nvSpPr>
-          <p:cNvPr id="4" name="TextBox 3"/>
-          <p:cNvSpPr txBox="1"/>
-          <p:nvPr/>
-        </p:nvSpPr>
-        <p:spPr>
-          <a:xfrm>
-            <a:off x="822960" y="4206240"/>
-            <a:ext cx="10515600" cy="1463040"/>
-          </a:xfrm>
-          <a:prstGeom prst="rect">
-            <a:avLst/>
-          </a:prstGeom>
-          <a:noFill/>
-        </p:spPr>
-        <p:txBody>
-          <a:bodyPr wrap="square" anchor="ctr">
-            <a:spAutoFit/>
-          </a:bodyPr>
-          <a:lstStyle/>
-          <a:p>
-            <a:pPr algn="ctr"/>
-            <a:r>
-              <a:rPr sz="2600" b="0">
-                <a:solidFill>
-                  <a:srgbClr val="041E42"/>
-                </a:solidFill>
-                <a:latin typeface="Calibri"/>
-              </a:rPr>
-              <a:t>Know yourself · Set a goal · Make a plan · See how you grow</a:t>
+              <a:t>Know yourself</a:t>
+            </a:r>
+          </a:p>
+        </p:txBody>
+      </p:sp>
+      <p:pic>
+        <p:nvPicPr>
+          <p:cNvPr id="5" name="Picture 4" descr="obj-goal.png"/>
+          <p:cNvPicPr>
+            <a:picLocks noChangeAspect="1"/>
+          </p:cNvPicPr>
+          <p:nvPr/>
+        </p:nvPicPr>
+        <p:blipFill>
+          <a:blip r:embed="rId3"/>
+          <a:stretch>
+            <a:fillRect/>
+          </a:stretch>
+        </p:blipFill>
+        <p:spPr>
+          <a:xfrm>
+            <a:off x="3889126" y="2286000"/>
+            <a:ext cx="1645920" cy="1645920"/>
+          </a:xfrm>
+          <a:prstGeom prst="rect">
+            <a:avLst/>
+          </a:prstGeom>
+        </p:spPr>
+      </p:pic>
+      <p:sp>
+        <p:nvSpPr>
+          <p:cNvPr id="6" name="TextBox 5"/>
+          <p:cNvSpPr txBox="1"/>
+          <p:nvPr/>
+        </p:nvSpPr>
+        <p:spPr>
+          <a:xfrm>
+            <a:off x="3614806" y="4023359"/>
+            <a:ext cx="2194560" cy="822960"/>
+          </a:xfrm>
+          <a:prstGeom prst="rect">
+            <a:avLst/>
+          </a:prstGeom>
+          <a:noFill/>
+        </p:spPr>
+        <p:txBody>
+          <a:bodyPr wrap="square" anchor="ctr">
+            <a:spAutoFit/>
+          </a:bodyPr>
+          <a:lstStyle/>
+          <a:p>
+            <a:pPr algn="ctr"/>
+            <a:r>
+              <a:rPr sz="1700" b="1">
+                <a:solidFill>
+                  <a:srgbClr val="004976"/>
+                </a:solidFill>
+                <a:latin typeface="Calibri"/>
+              </a:rPr>
+              <a:t>Set a goal</a:t>
+            </a:r>
+          </a:p>
+        </p:txBody>
+      </p:sp>
+      <p:pic>
+        <p:nvPicPr>
+          <p:cNvPr id="7" name="Picture 6" descr="obj-plan.png"/>
+          <p:cNvPicPr>
+            <a:picLocks noChangeAspect="1"/>
+          </p:cNvPicPr>
+          <p:nvPr/>
+        </p:nvPicPr>
+        <p:blipFill>
+          <a:blip r:embed="rId4"/>
+          <a:stretch>
+            <a:fillRect/>
+          </a:stretch>
+        </p:blipFill>
+        <p:spPr>
+          <a:xfrm>
+            <a:off x="6656649" y="2286000"/>
+            <a:ext cx="1645920" cy="1645920"/>
+          </a:xfrm>
+          <a:prstGeom prst="rect">
+            <a:avLst/>
+          </a:prstGeom>
+        </p:spPr>
+      </p:pic>
+      <p:sp>
+        <p:nvSpPr>
+          <p:cNvPr id="8" name="TextBox 7"/>
+          <p:cNvSpPr txBox="1"/>
+          <p:nvPr/>
+        </p:nvSpPr>
+        <p:spPr>
+          <a:xfrm>
+            <a:off x="6382329" y="4023359"/>
+            <a:ext cx="2194560" cy="822960"/>
+          </a:xfrm>
+          <a:prstGeom prst="rect">
+            <a:avLst/>
+          </a:prstGeom>
+          <a:noFill/>
+        </p:spPr>
+        <p:txBody>
+          <a:bodyPr wrap="square" anchor="ctr">
+            <a:spAutoFit/>
+          </a:bodyPr>
+          <a:lstStyle/>
+          <a:p>
+            <a:pPr algn="ctr"/>
+            <a:r>
+              <a:rPr sz="1700" b="1">
+                <a:solidFill>
+                  <a:srgbClr val="004976"/>
+                </a:solidFill>
+                <a:latin typeface="Calibri"/>
+              </a:rPr>
+              <a:t>Make a plan</a:t>
+            </a:r>
+          </a:p>
+        </p:txBody>
+      </p:sp>
+      <p:pic>
+        <p:nvPicPr>
+          <p:cNvPr id="9" name="Picture 8" descr="obj-grow.png"/>
+          <p:cNvPicPr>
+            <a:picLocks noChangeAspect="1"/>
+          </p:cNvPicPr>
+          <p:nvPr/>
+        </p:nvPicPr>
+        <p:blipFill>
+          <a:blip r:embed="rId5"/>
+          <a:stretch>
+            <a:fillRect/>
+          </a:stretch>
+        </p:blipFill>
+        <p:spPr>
+          <a:xfrm>
+            <a:off x="9424172" y="2286000"/>
+            <a:ext cx="1645920" cy="1645920"/>
+          </a:xfrm>
+          <a:prstGeom prst="rect">
+            <a:avLst/>
+          </a:prstGeom>
+        </p:spPr>
+      </p:pic>
+      <p:sp>
+        <p:nvSpPr>
+          <p:cNvPr id="10" name="TextBox 9"/>
+          <p:cNvSpPr txBox="1"/>
+          <p:nvPr/>
+        </p:nvSpPr>
+        <p:spPr>
+          <a:xfrm>
+            <a:off x="9149852" y="4023359"/>
+            <a:ext cx="2194560" cy="822960"/>
+          </a:xfrm>
+          <a:prstGeom prst="rect">
+            <a:avLst/>
+          </a:prstGeom>
+          <a:noFill/>
+        </p:spPr>
+        <p:txBody>
+          <a:bodyPr wrap="square" anchor="ctr">
+            <a:spAutoFit/>
+          </a:bodyPr>
+          <a:lstStyle/>
+          <a:p>
+            <a:pPr algn="ctr"/>
+            <a:r>
+              <a:rPr sz="1700" b="1">
+                <a:solidFill>
+                  <a:srgbClr val="004976"/>
+                </a:solidFill>
+                <a:latin typeface="Calibri"/>
+              </a:rPr>
+              <a:t>See how you grow</a:t>
             </a:r>
           </a:p>
         </p:txBody>

</xml_diff>